<commit_message>
feat: rebrand app to 모두예약 and refresh Android assets
- replace legacy venue branding and examples across app UI, docs, and presentation assets

- apply new 모두예약 naming to app label, login title, and Android listener label

- add and wire new generated logo source, regenerate launcher icons, and update splash resources for pre-Android 12 and Android 12+

- normalize app background and icon/splash background color to #FEFEFE for consistent visual surfaces

- harden tenant list loading so inaccessible tenant documents are skipped instead of failing the full store list

- add rollout summary doc covering branding, device validation, App Check issue, and release signing caveat
</commit_message>
<xml_diff>
--- a/presentation/presentation.pptx
+++ b/presentation/presentation.pptx
@@ -2927,7 +2927,7 @@
                 <a:ea typeface="Pretendard" pitchFamily="34" charset="-122"/>
                 <a:cs typeface="Pretendard" pitchFamily="34" charset="-120"/>
               </a:rPr>
-              <a:t>• 홀덤펍: 시팅 및 참가 예약</a:t>
+              <a:t>• 실내 스포츠 센터: 그룹 세션 예약</a:t>
             </a:r>
             <a:endParaRPr lang="en-US" sz="1350" dirty="0"/>
           </a:p>
@@ -6604,7 +6604,7 @@
                 <a:ea typeface="Pretendard" pitchFamily="34" charset="-122"/>
                 <a:cs typeface="Pretendard" pitchFamily="34" charset="-120"/>
               </a:rPr>
-              <a:t>A 홀덤펍 강남점
+              <a:t>A 실내 스포츠 라운지 강남점
 </a:t>
             </a:r>
             <a:pPr indent="0" marL="0">

</xml_diff>